<commit_message>
docs: link the 24s demo video from the deck and submission notes
</commit_message>
<xml_diff>
--- a/submission/VTU-QFF-HC-0024.pptx
+++ b/submission/VTU-QFF-HC-0024.pptx
@@ -601,7 +601,7 @@
           <a:lstStyle/>
           <a:p>
             <a:r>
-              <a:t>Public repo: https://github.com/vtu-qiskit-fall-fest-2026/vtu-hc-q-matrix. Live demo: https://chinmayrerc.github.io/q-matrix/. API: https://q-matrix.onrender.com.</a:t>
+              <a:t>Public repo: https://github.com/vtu-qiskit-fall-fest-2026/vtu-hc-q-matrix. Live demo: https://chinmayrerc.github.io/q-matrix/. Demo video: https://github.com/ChinmayRERC/q-matrix/blob/main/docs/q-matrix-demo.mp4. API: https://q-matrix.onrender.com.</a:t>
             </a:r>
           </a:p>
         </p:txBody>
@@ -4197,8 +4197,8 @@
         </p:nvSpPr>
         <p:spPr>
           <a:xfrm>
-            <a:off x="457200" y="3968496"/>
-            <a:ext cx="4937760" cy="713232"/>
+            <a:off x="457200" y="3675887"/>
+            <a:ext cx="4937760" cy="969264"/>
           </a:xfrm>
           <a:prstGeom prst="rect">
             <a:avLst/>
@@ -4240,6 +4240,23 @@
                 </a:solidFill>
                 <a:latin typeface="Calibri"/>
                 <a:hlinkClick r:id="rId9"/>
+              </a:rPr>
+              <a:t>Demo video (24 s) · github.com/ChinmayRERC/q-matrix/blob/main/docs/q-matrix-demo.mp4</a:t>
+            </a:r>
+          </a:p>
+          <a:p>
+            <a:pPr>
+              <a:spcAft>
+                <a:spcPts val="150"/>
+              </a:spcAft>
+            </a:pPr>
+            <a:r>
+              <a:rPr sz="800" b="0" i="0">
+                <a:solidFill>
+                  <a:srgbClr val="2E1B5B"/>
+                </a:solidFill>
+                <a:latin typeface="Calibri"/>
+                <a:hlinkClick r:id="rId10"/>
               </a:rPr>
               <a:t>API · https://q-matrix.onrender.com</a:t>
             </a:r>

</xml_diff>